<commit_message>
Improve editable organizational diagrams
</commit_message>
<xml_diff>
--- a/docs/organizational-diagrams.pptx
+++ b/docs/organizational-diagrams.pptx
@@ -961,12 +961,12 @@
         </p:nvSpPr>
         <p:spPr>
           <a:xfrm>
-            <a:off x="2103120" y="777240"/>
-            <a:ext cx="2423160" cy="530352"/>
+            <a:off x="2331720" y="777240"/>
+            <a:ext cx="2743200" cy="566928"/>
           </a:xfrm>
           <a:prstGeom prst="roundRect">
             <a:avLst>
-              <a:gd name="adj" fmla="val 13793"/>
+              <a:gd name="adj" fmla="val 12903"/>
             </a:avLst>
           </a:prstGeom>
           <a:solidFill>
@@ -988,8 +988,8 @@
         </p:nvSpPr>
         <p:spPr>
           <a:xfrm>
-            <a:off x="2148840" y="850392"/>
-            <a:ext cx="2331720" cy="384048"/>
+            <a:off x="2377440" y="850392"/>
+            <a:ext cx="2651760" cy="420624"/>
           </a:xfrm>
           <a:prstGeom prst="rect">
             <a:avLst/>
@@ -1029,12 +1029,12 @@
         </p:nvSpPr>
         <p:spPr>
           <a:xfrm>
-            <a:off x="594360" y="1783080"/>
-            <a:ext cx="1783080" cy="502920"/>
+            <a:off x="411480" y="1783080"/>
+            <a:ext cx="2148840" cy="566928"/>
           </a:xfrm>
           <a:prstGeom prst="roundRect">
             <a:avLst>
-              <a:gd name="adj" fmla="val 14545"/>
+              <a:gd name="adj" fmla="val 12903"/>
             </a:avLst>
           </a:prstGeom>
           <a:solidFill>
@@ -1056,8 +1056,8 @@
         </p:nvSpPr>
         <p:spPr>
           <a:xfrm>
-            <a:off x="640080" y="1856232"/>
-            <a:ext cx="1691640" cy="356616"/>
+            <a:off x="457200" y="1856232"/>
+            <a:ext cx="2057400" cy="420624"/>
           </a:xfrm>
           <a:prstGeom prst="rect">
             <a:avLst/>
@@ -1097,12 +1097,12 @@
         </p:nvSpPr>
         <p:spPr>
           <a:xfrm>
-            <a:off x="2697480" y="1783080"/>
-            <a:ext cx="1783080" cy="502920"/>
+            <a:off x="2788920" y="1783080"/>
+            <a:ext cx="2057400" cy="566928"/>
           </a:xfrm>
           <a:prstGeom prst="roundRect">
             <a:avLst>
-              <a:gd name="adj" fmla="val 14545"/>
+              <a:gd name="adj" fmla="val 12903"/>
             </a:avLst>
           </a:prstGeom>
           <a:solidFill>
@@ -1124,8 +1124,8 @@
         </p:nvSpPr>
         <p:spPr>
           <a:xfrm>
-            <a:off x="2743200" y="1856232"/>
-            <a:ext cx="1691640" cy="356616"/>
+            <a:off x="2834640" y="1856232"/>
+            <a:ext cx="1965960" cy="420624"/>
           </a:xfrm>
           <a:prstGeom prst="rect">
             <a:avLst/>
@@ -1165,12 +1165,12 @@
         </p:nvSpPr>
         <p:spPr>
           <a:xfrm>
-            <a:off x="4800600" y="1783080"/>
-            <a:ext cx="1965960" cy="502920"/>
+            <a:off x="5257800" y="1783080"/>
+            <a:ext cx="2331720" cy="566928"/>
           </a:xfrm>
           <a:prstGeom prst="roundRect">
             <a:avLst>
-              <a:gd name="adj" fmla="val 14545"/>
+              <a:gd name="adj" fmla="val 12903"/>
             </a:avLst>
           </a:prstGeom>
           <a:solidFill>
@@ -1192,8 +1192,8 @@
         </p:nvSpPr>
         <p:spPr>
           <a:xfrm>
-            <a:off x="4846320" y="1856232"/>
-            <a:ext cx="1874520" cy="356616"/>
+            <a:off x="5303520" y="1856232"/>
+            <a:ext cx="2240280" cy="420624"/>
           </a:xfrm>
           <a:prstGeom prst="rect">
             <a:avLst/>
@@ -1233,12 +1233,12 @@
         </p:nvSpPr>
         <p:spPr>
           <a:xfrm>
-            <a:off x="594360" y="2697480"/>
-            <a:ext cx="1783080" cy="548640"/>
+            <a:off x="320040" y="2724912"/>
+            <a:ext cx="2331720" cy="621792"/>
           </a:xfrm>
           <a:prstGeom prst="roundRect">
             <a:avLst>
-              <a:gd name="adj" fmla="val 13333"/>
+              <a:gd name="adj" fmla="val 11765"/>
             </a:avLst>
           </a:prstGeom>
           <a:solidFill>
@@ -1260,8 +1260,8 @@
         </p:nvSpPr>
         <p:spPr>
           <a:xfrm>
-            <a:off x="640080" y="2770632"/>
-            <a:ext cx="1691640" cy="402336"/>
+            <a:off x="365760" y="2798064"/>
+            <a:ext cx="2240280" cy="475488"/>
           </a:xfrm>
           <a:prstGeom prst="rect">
             <a:avLst/>
@@ -1301,12 +1301,12 @@
         </p:nvSpPr>
         <p:spPr>
           <a:xfrm>
-            <a:off x="2697480" y="2697480"/>
-            <a:ext cx="1783080" cy="502920"/>
+            <a:off x="2788920" y="2724912"/>
+            <a:ext cx="2057400" cy="566928"/>
           </a:xfrm>
           <a:prstGeom prst="roundRect">
             <a:avLst>
-              <a:gd name="adj" fmla="val 14545"/>
+              <a:gd name="adj" fmla="val 12903"/>
             </a:avLst>
           </a:prstGeom>
           <a:solidFill>
@@ -1328,8 +1328,8 @@
         </p:nvSpPr>
         <p:spPr>
           <a:xfrm>
-            <a:off x="2743200" y="2770632"/>
-            <a:ext cx="1691640" cy="356616"/>
+            <a:off x="2834640" y="2798064"/>
+            <a:ext cx="1965960" cy="420624"/>
           </a:xfrm>
           <a:prstGeom prst="rect">
             <a:avLst/>
@@ -1369,12 +1369,12 @@
         </p:nvSpPr>
         <p:spPr>
           <a:xfrm>
-            <a:off x="4892040" y="2697480"/>
-            <a:ext cx="1783080" cy="502920"/>
+            <a:off x="5394960" y="2724912"/>
+            <a:ext cx="2057400" cy="566928"/>
           </a:xfrm>
           <a:prstGeom prst="roundRect">
             <a:avLst>
-              <a:gd name="adj" fmla="val 14545"/>
+              <a:gd name="adj" fmla="val 12903"/>
             </a:avLst>
           </a:prstGeom>
           <a:solidFill>
@@ -1396,8 +1396,8 @@
         </p:nvSpPr>
         <p:spPr>
           <a:xfrm>
-            <a:off x="4937760" y="2770632"/>
-            <a:ext cx="1691640" cy="356616"/>
+            <a:off x="5440680" y="2798064"/>
+            <a:ext cx="1965960" cy="420624"/>
           </a:xfrm>
           <a:prstGeom prst="rect">
             <a:avLst/>
@@ -1437,12 +1437,12 @@
         </p:nvSpPr>
         <p:spPr>
           <a:xfrm>
-            <a:off x="594360" y="3611880"/>
-            <a:ext cx="1783080" cy="502920"/>
+            <a:off x="320040" y="3675888"/>
+            <a:ext cx="2331720" cy="566928"/>
           </a:xfrm>
           <a:prstGeom prst="roundRect">
             <a:avLst>
-              <a:gd name="adj" fmla="val 14545"/>
+              <a:gd name="adj" fmla="val 12903"/>
             </a:avLst>
           </a:prstGeom>
           <a:solidFill>
@@ -1464,8 +1464,8 @@
         </p:nvSpPr>
         <p:spPr>
           <a:xfrm>
-            <a:off x="640080" y="3685032"/>
-            <a:ext cx="1691640" cy="356616"/>
+            <a:off x="365760" y="3749040"/>
+            <a:ext cx="2240280" cy="420624"/>
           </a:xfrm>
           <a:prstGeom prst="rect">
             <a:avLst/>
@@ -1505,12 +1505,12 @@
         </p:nvSpPr>
         <p:spPr>
           <a:xfrm>
-            <a:off x="2697480" y="3611880"/>
-            <a:ext cx="1783080" cy="502920"/>
+            <a:off x="2788920" y="3675888"/>
+            <a:ext cx="2057400" cy="566928"/>
           </a:xfrm>
           <a:prstGeom prst="roundRect">
             <a:avLst>
-              <a:gd name="adj" fmla="val 14545"/>
+              <a:gd name="adj" fmla="val 12903"/>
             </a:avLst>
           </a:prstGeom>
           <a:solidFill>
@@ -1532,8 +1532,8 @@
         </p:nvSpPr>
         <p:spPr>
           <a:xfrm>
-            <a:off x="2743200" y="3685032"/>
-            <a:ext cx="1691640" cy="356616"/>
+            <a:off x="2834640" y="3749040"/>
+            <a:ext cx="1965960" cy="420624"/>
           </a:xfrm>
           <a:prstGeom prst="rect">
             <a:avLst/>
@@ -1573,12 +1573,12 @@
         </p:nvSpPr>
         <p:spPr>
           <a:xfrm>
-            <a:off x="594360" y="4526280"/>
-            <a:ext cx="1783080" cy="502920"/>
+            <a:off x="320040" y="4617720"/>
+            <a:ext cx="2331720" cy="566928"/>
           </a:xfrm>
           <a:prstGeom prst="roundRect">
             <a:avLst>
-              <a:gd name="adj" fmla="val 14545"/>
+              <a:gd name="adj" fmla="val 12903"/>
             </a:avLst>
           </a:prstGeom>
           <a:solidFill>
@@ -1600,8 +1600,8 @@
         </p:nvSpPr>
         <p:spPr>
           <a:xfrm>
-            <a:off x="640080" y="4599432"/>
-            <a:ext cx="1691640" cy="356616"/>
+            <a:off x="365760" y="4690872"/>
+            <a:ext cx="2240280" cy="420624"/>
           </a:xfrm>
           <a:prstGeom prst="rect">
             <a:avLst/>
@@ -1641,12 +1641,12 @@
         </p:nvSpPr>
         <p:spPr>
           <a:xfrm>
-            <a:off x="594360" y="5440680"/>
-            <a:ext cx="1783080" cy="502920"/>
+            <a:off x="320040" y="5559552"/>
+            <a:ext cx="2331720" cy="566928"/>
           </a:xfrm>
           <a:prstGeom prst="roundRect">
             <a:avLst>
-              <a:gd name="adj" fmla="val 14545"/>
+              <a:gd name="adj" fmla="val 12903"/>
             </a:avLst>
           </a:prstGeom>
           <a:solidFill>
@@ -1668,8 +1668,8 @@
         </p:nvSpPr>
         <p:spPr>
           <a:xfrm>
-            <a:off x="640080" y="5513832"/>
-            <a:ext cx="1691640" cy="356616"/>
+            <a:off x="365760" y="5632704"/>
+            <a:ext cx="2240280" cy="420624"/>
           </a:xfrm>
           <a:prstGeom prst="rect">
             <a:avLst/>
@@ -1709,8 +1709,8 @@
         </p:nvSpPr>
         <p:spPr>
           <a:xfrm>
-            <a:off x="3319272" y="1307592"/>
-            <a:ext cx="-1828800" cy="475488"/>
+            <a:off x="1060704" y="914400"/>
+            <a:ext cx="1005840" cy="914400"/>
           </a:xfrm>
           <a:prstGeom prst="line">
             <a:avLst/>
@@ -1734,8 +1734,8 @@
         </p:nvSpPr>
         <p:spPr>
           <a:xfrm>
-            <a:off x="3319272" y="1307592"/>
-            <a:ext cx="274320" cy="475488"/>
+            <a:off x="1060704" y="914400"/>
+            <a:ext cx="1005840" cy="914400"/>
           </a:xfrm>
           <a:prstGeom prst="line">
             <a:avLst/>
@@ -1759,8 +1759,8 @@
         </p:nvSpPr>
         <p:spPr>
           <a:xfrm>
-            <a:off x="3319272" y="1307592"/>
-            <a:ext cx="2468880" cy="475488"/>
+            <a:off x="1060704" y="914400"/>
+            <a:ext cx="1005840" cy="914400"/>
           </a:xfrm>
           <a:prstGeom prst="line">
             <a:avLst/>
@@ -1784,8 +1784,8 @@
         </p:nvSpPr>
         <p:spPr>
           <a:xfrm>
-            <a:off x="1490472" y="2286000"/>
-            <a:ext cx="0" cy="411480"/>
+            <a:off x="2066544" y="914400"/>
+            <a:ext cx="969264" cy="914400"/>
           </a:xfrm>
           <a:prstGeom prst="line">
             <a:avLst/>
@@ -1809,8 +1809,8 @@
         </p:nvSpPr>
         <p:spPr>
           <a:xfrm>
-            <a:off x="3593592" y="2286000"/>
-            <a:ext cx="0" cy="411480"/>
+            <a:off x="2066544" y="914400"/>
+            <a:ext cx="941832" cy="914400"/>
           </a:xfrm>
           <a:prstGeom prst="line">
             <a:avLst/>
@@ -1834,8 +1834,8 @@
         </p:nvSpPr>
         <p:spPr>
           <a:xfrm>
-            <a:off x="5788152" y="2286000"/>
-            <a:ext cx="0" cy="411480"/>
+            <a:off x="2066544" y="914400"/>
+            <a:ext cx="941832" cy="914400"/>
           </a:xfrm>
           <a:prstGeom prst="line">
             <a:avLst/>
@@ -1859,8 +1859,8 @@
         </p:nvSpPr>
         <p:spPr>
           <a:xfrm>
-            <a:off x="1490472" y="3246120"/>
-            <a:ext cx="0" cy="365760"/>
+            <a:off x="3035808" y="914400"/>
+            <a:ext cx="923544" cy="914400"/>
           </a:xfrm>
           <a:prstGeom prst="line">
             <a:avLst/>
@@ -1884,8 +1884,8 @@
         </p:nvSpPr>
         <p:spPr>
           <a:xfrm>
-            <a:off x="3593592" y="3200400"/>
-            <a:ext cx="0" cy="411480"/>
+            <a:off x="3008376" y="914400"/>
+            <a:ext cx="950976" cy="914400"/>
           </a:xfrm>
           <a:prstGeom prst="line">
             <a:avLst/>
@@ -1909,8 +1909,8 @@
         </p:nvSpPr>
         <p:spPr>
           <a:xfrm>
-            <a:off x="1490472" y="4114800"/>
-            <a:ext cx="0" cy="411480"/>
+            <a:off x="3959352" y="914400"/>
+            <a:ext cx="941832" cy="914400"/>
           </a:xfrm>
           <a:prstGeom prst="line">
             <a:avLst/>
@@ -1934,8 +1934,8 @@
         </p:nvSpPr>
         <p:spPr>
           <a:xfrm>
-            <a:off x="1490472" y="5029200"/>
-            <a:ext cx="0" cy="411480"/>
+            <a:off x="4901184" y="914400"/>
+            <a:ext cx="941832" cy="914400"/>
           </a:xfrm>
           <a:prstGeom prst="line">
             <a:avLst/>
@@ -1959,12 +1959,12 @@
         </p:nvSpPr>
         <p:spPr>
           <a:xfrm>
-            <a:off x="8412480" y="777240"/>
-            <a:ext cx="2331720" cy="530352"/>
+            <a:off x="8275320" y="777240"/>
+            <a:ext cx="2743200" cy="566928"/>
           </a:xfrm>
           <a:prstGeom prst="roundRect">
             <a:avLst>
-              <a:gd name="adj" fmla="val 13793"/>
+              <a:gd name="adj" fmla="val 12903"/>
             </a:avLst>
           </a:prstGeom>
           <a:solidFill>
@@ -1986,8 +1986,8 @@
         </p:nvSpPr>
         <p:spPr>
           <a:xfrm>
-            <a:off x="8458200" y="850392"/>
-            <a:ext cx="2240280" cy="384048"/>
+            <a:off x="8321040" y="850392"/>
+            <a:ext cx="2651760" cy="420624"/>
           </a:xfrm>
           <a:prstGeom prst="rect">
             <a:avLst/>
@@ -2027,12 +2027,12 @@
         </p:nvSpPr>
         <p:spPr>
           <a:xfrm>
-            <a:off x="8549640" y="1783080"/>
-            <a:ext cx="2057400" cy="502920"/>
+            <a:off x="8458200" y="1783080"/>
+            <a:ext cx="2377440" cy="566928"/>
           </a:xfrm>
           <a:prstGeom prst="roundRect">
             <a:avLst>
-              <a:gd name="adj" fmla="val 14545"/>
+              <a:gd name="adj" fmla="val 12903"/>
             </a:avLst>
           </a:prstGeom>
           <a:solidFill>
@@ -2054,8 +2054,8 @@
         </p:nvSpPr>
         <p:spPr>
           <a:xfrm>
-            <a:off x="8595360" y="1856232"/>
-            <a:ext cx="1965960" cy="356616"/>
+            <a:off x="8503920" y="1856232"/>
+            <a:ext cx="2286000" cy="420624"/>
           </a:xfrm>
           <a:prstGeom prst="rect">
             <a:avLst/>
@@ -2095,12 +2095,12 @@
         </p:nvSpPr>
         <p:spPr>
           <a:xfrm>
-            <a:off x="8549640" y="2697480"/>
-            <a:ext cx="2057400" cy="502920"/>
+            <a:off x="8458200" y="2724912"/>
+            <a:ext cx="2377440" cy="566928"/>
           </a:xfrm>
           <a:prstGeom prst="roundRect">
             <a:avLst>
-              <a:gd name="adj" fmla="val 14545"/>
+              <a:gd name="adj" fmla="val 12903"/>
             </a:avLst>
           </a:prstGeom>
           <a:solidFill>
@@ -2122,8 +2122,8 @@
         </p:nvSpPr>
         <p:spPr>
           <a:xfrm>
-            <a:off x="8595360" y="2770632"/>
-            <a:ext cx="1965960" cy="356616"/>
+            <a:off x="8503920" y="2798064"/>
+            <a:ext cx="2286000" cy="420624"/>
           </a:xfrm>
           <a:prstGeom prst="rect">
             <a:avLst/>
@@ -2163,12 +2163,12 @@
         </p:nvSpPr>
         <p:spPr>
           <a:xfrm>
-            <a:off x="8549640" y="3611880"/>
-            <a:ext cx="2057400" cy="502920"/>
+            <a:off x="8458200" y="3675888"/>
+            <a:ext cx="2377440" cy="566928"/>
           </a:xfrm>
           <a:prstGeom prst="roundRect">
             <a:avLst>
-              <a:gd name="adj" fmla="val 14545"/>
+              <a:gd name="adj" fmla="val 12903"/>
             </a:avLst>
           </a:prstGeom>
           <a:solidFill>
@@ -2190,8 +2190,8 @@
         </p:nvSpPr>
         <p:spPr>
           <a:xfrm>
-            <a:off x="8595360" y="3685032"/>
-            <a:ext cx="1965960" cy="356616"/>
+            <a:off x="8503920" y="3749040"/>
+            <a:ext cx="2286000" cy="420624"/>
           </a:xfrm>
           <a:prstGeom prst="rect">
             <a:avLst/>
@@ -2231,12 +2231,12 @@
         </p:nvSpPr>
         <p:spPr>
           <a:xfrm>
-            <a:off x="8549640" y="4526280"/>
-            <a:ext cx="2057400" cy="502920"/>
+            <a:off x="8458200" y="4617720"/>
+            <a:ext cx="2377440" cy="566928"/>
           </a:xfrm>
           <a:prstGeom prst="roundRect">
             <a:avLst>
-              <a:gd name="adj" fmla="val 14545"/>
+              <a:gd name="adj" fmla="val 12903"/>
             </a:avLst>
           </a:prstGeom>
           <a:solidFill>
@@ -2258,8 +2258,8 @@
         </p:nvSpPr>
         <p:spPr>
           <a:xfrm>
-            <a:off x="8595360" y="4599432"/>
-            <a:ext cx="1965960" cy="356616"/>
+            <a:off x="8503920" y="4690872"/>
+            <a:ext cx="2286000" cy="420624"/>
           </a:xfrm>
           <a:prstGeom prst="rect">
             <a:avLst/>
@@ -2299,12 +2299,12 @@
         </p:nvSpPr>
         <p:spPr>
           <a:xfrm>
-            <a:off x="8549640" y="5440680"/>
-            <a:ext cx="2057400" cy="502920"/>
+            <a:off x="8458200" y="5559552"/>
+            <a:ext cx="2377440" cy="566928"/>
           </a:xfrm>
           <a:prstGeom prst="roundRect">
             <a:avLst>
-              <a:gd name="adj" fmla="val 14545"/>
+              <a:gd name="adj" fmla="val 12903"/>
             </a:avLst>
           </a:prstGeom>
           <a:solidFill>
@@ -2326,8 +2326,8 @@
         </p:nvSpPr>
         <p:spPr>
           <a:xfrm>
-            <a:off x="8595360" y="5513832"/>
-            <a:ext cx="1965960" cy="356616"/>
+            <a:off x="8503920" y="5632704"/>
+            <a:ext cx="2286000" cy="420624"/>
           </a:xfrm>
           <a:prstGeom prst="rect">
             <a:avLst/>
@@ -2367,8 +2367,8 @@
         </p:nvSpPr>
         <p:spPr>
           <a:xfrm>
-            <a:off x="9578340" y="1307592"/>
-            <a:ext cx="0" cy="475488"/>
+            <a:off x="9646920" y="1344168"/>
+            <a:ext cx="0" cy="438912"/>
           </a:xfrm>
           <a:prstGeom prst="line">
             <a:avLst/>
@@ -2392,8 +2392,8 @@
         </p:nvSpPr>
         <p:spPr>
           <a:xfrm>
-            <a:off x="9578340" y="2286000"/>
-            <a:ext cx="0" cy="411480"/>
+            <a:off x="9646920" y="2350008"/>
+            <a:ext cx="0" cy="374904"/>
           </a:xfrm>
           <a:prstGeom prst="line">
             <a:avLst/>
@@ -2417,8 +2417,8 @@
         </p:nvSpPr>
         <p:spPr>
           <a:xfrm>
-            <a:off x="9578340" y="3200400"/>
-            <a:ext cx="0" cy="411480"/>
+            <a:off x="9646920" y="3291840"/>
+            <a:ext cx="0" cy="384048"/>
           </a:xfrm>
           <a:prstGeom prst="line">
             <a:avLst/>
@@ -2442,8 +2442,8 @@
         </p:nvSpPr>
         <p:spPr>
           <a:xfrm>
-            <a:off x="9578340" y="4114800"/>
-            <a:ext cx="0" cy="411480"/>
+            <a:off x="9646920" y="4242816"/>
+            <a:ext cx="0" cy="374904"/>
           </a:xfrm>
           <a:prstGeom prst="line">
             <a:avLst/>
@@ -2467,8 +2467,8 @@
         </p:nvSpPr>
         <p:spPr>
           <a:xfrm>
-            <a:off x="9578340" y="5029200"/>
-            <a:ext cx="0" cy="411480"/>
+            <a:off x="9646920" y="5184648"/>
+            <a:ext cx="0" cy="374904"/>
           </a:xfrm>
           <a:prstGeom prst="line">
             <a:avLst/>

</xml_diff>